<commit_message>
User guide: overview reports, dormant rule and dormant list (new slide 12)
Slide 6 describes the report counter and the 23 per-ward sites; new slide 12
covers Site Overview, Area Summary, the 4-month dormant rule and the dormant
list; routine step 6 now includes reviewing the dormant list.

Co-Authored-By: Claude Fable 5.1 <noreply@anthropic.com>
</commit_message>
<xml_diff>
--- a/PQ_Report_Generator_User_Guide.pptx
+++ b/PQ_Report_Generator_User_Guide.pptx
@@ -16,6 +16,7 @@
     <p:sldId id="264" r:id="rId10"/>
     <p:sldId id="265" r:id="rId11"/>
     <p:sldId id="266" r:id="rId12"/>
+    <p:sldId id="273" r:id="rId24"/>
     <p:sldId id="267" r:id="rId13"/>
     <p:sldId id="268" r:id="rId14"/>
     <p:sldId id="269" r:id="rId15"/>
@@ -8576,6 +8577,10 @@
           </a:solidFill>
           <a:ln/>
         </p:spPr>
+        <p:txBody>
+          <a:bodyPr/>
+          <a:p/>
+        </p:txBody>
       </p:sp>
       <p:sp>
         <p:nvSpPr>
@@ -8677,6 +8682,10 @@
             <a:prstDash val="solid"/>
           </a:ln>
         </p:spPr>
+        <p:txBody>
+          <a:bodyPr/>
+          <a:p/>
+        </p:txBody>
       </p:sp>
       <p:sp>
         <p:nvSpPr>
@@ -8697,6 +8706,10 @@
           </a:solidFill>
           <a:ln/>
         </p:spPr>
+        <p:txBody>
+          <a:bodyPr/>
+          <a:p/>
+        </p:txBody>
       </p:sp>
       <p:sp>
         <p:nvSpPr>
@@ -8798,6 +8811,10 @@
             <a:prstDash val="solid"/>
           </a:ln>
         </p:spPr>
+        <p:txBody>
+          <a:bodyPr/>
+          <a:p/>
+        </p:txBody>
       </p:sp>
       <p:sp>
         <p:nvSpPr>
@@ -8818,6 +8835,10 @@
           </a:solidFill>
           <a:ln/>
         </p:spPr>
+        <p:txBody>
+          <a:bodyPr/>
+          <a:p/>
+        </p:txBody>
       </p:sp>
       <p:sp>
         <p:nvSpPr>
@@ -8919,6 +8940,10 @@
             <a:prstDash val="solid"/>
           </a:ln>
         </p:spPr>
+        <p:txBody>
+          <a:bodyPr/>
+          <a:p/>
+        </p:txBody>
       </p:sp>
       <p:sp>
         <p:nvSpPr>
@@ -8939,6 +8964,10 @@
           </a:solidFill>
           <a:ln/>
         </p:spPr>
+        <p:txBody>
+          <a:bodyPr/>
+          <a:p/>
+        </p:txBody>
       </p:sp>
       <p:sp>
         <p:nvSpPr>
@@ -9040,6 +9069,10 @@
             <a:prstDash val="solid"/>
           </a:ln>
         </p:spPr>
+        <p:txBody>
+          <a:bodyPr/>
+          <a:p/>
+        </p:txBody>
       </p:sp>
       <p:sp>
         <p:nvSpPr>
@@ -9060,6 +9093,10 @@
           </a:solidFill>
           <a:ln/>
         </p:spPr>
+        <p:txBody>
+          <a:bodyPr/>
+          <a:p/>
+        </p:txBody>
       </p:sp>
       <p:sp>
         <p:nvSpPr>
@@ -9161,6 +9198,10 @@
             <a:prstDash val="solid"/>
           </a:ln>
         </p:spPr>
+        <p:txBody>
+          <a:bodyPr/>
+          <a:p/>
+        </p:txBody>
       </p:sp>
       <p:sp>
         <p:nvSpPr>
@@ -9181,6 +9222,10 @@
           </a:solidFill>
           <a:ln/>
         </p:spPr>
+        <p:txBody>
+          <a:bodyPr/>
+          <a:p/>
+        </p:txBody>
       </p:sp>
       <p:sp>
         <p:nvSpPr>
@@ -9254,7 +9299,7 @@
                 <a:ea typeface="Calibri" pitchFamily="34" charset="-122"/>
                 <a:cs typeface="Calibri" pitchFamily="34" charset="-120"/>
               </a:rPr>
-              <a:t>Review the Word reports, then distribute them</a:t>
+              <a:t>Review the Word reports and the dormant list, then distribute them</a:t>
             </a:r>
             <a:endParaRPr lang="en-US" sz="1450" dirty="0"/>
           </a:p>
@@ -11953,6 +11998,664 @@
 </p:sld>
 </file>
 
+<file path=ppt/slides/slide18.xml><?xml version="1.0" encoding="utf-8"?>
+<p:sld xmlns:a="http://schemas.openxmlformats.org/drawingml/2006/main" xmlns:p="http://schemas.openxmlformats.org/presentationml/2006/main" xmlns:r="http://schemas.openxmlformats.org/officeDocument/2006/relationships">
+  <p:cSld>
+    <p:spTree>
+      <p:nvGrpSpPr>
+        <p:cNvPr id="1" name=""/>
+        <p:cNvGrpSpPr/>
+        <p:nvPr/>
+      </p:nvGrpSpPr>
+      <p:grpSpPr/>
+      <p:sp>
+        <p:nvSpPr>
+          <p:cNvPr id="2" name="Text 0"/>
+          <p:cNvSpPr txBox="1"/>
+          <p:nvPr/>
+        </p:nvSpPr>
+        <p:spPr>
+          <a:xfrm>
+            <a:off x="548640" y="320040"/>
+            <a:ext cx="11064240" cy="685800"/>
+          </a:xfrm>
+          <a:prstGeom prst="rect">
+            <a:avLst/>
+          </a:prstGeom>
+          <a:noFill/>
+          <a:ln/>
+        </p:spPr>
+        <p:txBody>
+          <a:bodyPr wrap="square" lIns="0" tIns="0" rIns="0" bIns="0" rtlCol="0" anchor="ctr"/>
+          <a:lstStyle/>
+          <a:p>
+            <a:pPr indent="0" marL="0">
+              <a:buNone/>
+            </a:pPr>
+            <a:r>
+              <a:rPr lang="en-US" sz="3000" b="1" dirty="0">
+                <a:solidFill>
+                  <a:srgbClr val="01485C"/>
+                </a:solidFill>
+                <a:latin typeface="Calibri" pitchFamily="34" charset="0"/>
+                <a:ea typeface="Calibri" pitchFamily="34" charset="-122"/>
+                <a:cs typeface="Calibri" pitchFamily="34" charset="-120"/>
+              </a:rPr>
+              <a:t>Overview reports and the dormant list</a:t>
+            </a:r>
+            <a:endParaRPr lang="en-US" sz="3000" dirty="0"/>
+          </a:p>
+        </p:txBody>
+      </p:sp>
+      <p:sp>
+        <p:nvSpPr>
+          <p:cNvPr id="3" name="Shape 1"/>
+          <p:cNvSpPr/>
+          <p:nvPr/>
+        </p:nvSpPr>
+        <p:spPr>
+          <a:xfrm>
+            <a:off x="9784080" y="384048"/>
+            <a:ext cx="1828800" cy="457200"/>
+          </a:xfrm>
+          <a:prstGeom prst="roundRect">
+            <a:avLst>
+              <a:gd name="adj" fmla="val 50000"/>
+            </a:avLst>
+          </a:prstGeom>
+          <a:solidFill>
+            <a:srgbClr val="01485C"/>
+          </a:solidFill>
+          <a:ln/>
+        </p:spPr>
+        <p:txBody>
+          <a:bodyPr/>
+          <a:p/>
+        </p:txBody>
+      </p:sp>
+      <p:sp>
+        <p:nvSpPr>
+          <p:cNvPr id="4" name="Text 2"/>
+          <p:cNvSpPr txBox="1"/>
+          <p:nvPr/>
+        </p:nvSpPr>
+        <p:spPr>
+          <a:xfrm>
+            <a:off x="9784080" y="384048"/>
+            <a:ext cx="1828800" cy="457200"/>
+          </a:xfrm>
+          <a:prstGeom prst="rect">
+            <a:avLst/>
+          </a:prstGeom>
+          <a:noFill/>
+          <a:ln/>
+        </p:spPr>
+        <p:txBody>
+          <a:bodyPr wrap="square" lIns="0" tIns="0" rIns="0" bIns="0" rtlCol="0" anchor="ctr"/>
+          <a:lstStyle/>
+          <a:p>
+            <a:pPr algn="ctr" indent="0" marL="0">
+              <a:buNone/>
+            </a:pPr>
+            <a:r>
+              <a:rPr lang="en-US" sz="1500" b="1" dirty="0">
+                <a:solidFill>
+                  <a:srgbClr val="FFFFFF"/>
+                </a:solidFill>
+                <a:latin typeface="Calibri" pitchFamily="34" charset="0"/>
+                <a:ea typeface="Calibri" pitchFamily="34" charset="-122"/>
+                <a:cs typeface="Calibri" pitchFamily="34" charset="-120"/>
+              </a:rPr>
+              <a:t>i-STAT</a:t>
+            </a:r>
+            <a:endParaRPr lang="en-US" sz="1500" dirty="0"/>
+          </a:p>
+        </p:txBody>
+      </p:sp>
+      <p:sp>
+        <p:nvSpPr>
+          <p:cNvPr id="5" name="Shape 3"/>
+          <p:cNvSpPr/>
+          <p:nvPr/>
+        </p:nvSpPr>
+        <p:spPr>
+          <a:xfrm>
+            <a:off x="548640" y="1463040"/>
+            <a:ext cx="5486400" cy="2103120"/>
+          </a:xfrm>
+          <a:prstGeom prst="roundRect">
+            <a:avLst>
+              <a:gd name="adj" fmla="val 5217"/>
+            </a:avLst>
+          </a:prstGeom>
+          <a:solidFill>
+            <a:srgbClr val="E5F2F0"/>
+          </a:solidFill>
+          <a:ln/>
+        </p:spPr>
+        <p:txBody>
+          <a:bodyPr/>
+          <a:p/>
+        </p:txBody>
+      </p:sp>
+      <p:sp>
+        <p:nvSpPr>
+          <p:cNvPr id="6" name="Text 4"/>
+          <p:cNvSpPr txBox="1"/>
+          <p:nvPr/>
+        </p:nvSpPr>
+        <p:spPr>
+          <a:xfrm>
+            <a:off x="822960" y="1664208"/>
+            <a:ext cx="4937760" cy="411480"/>
+          </a:xfrm>
+          <a:prstGeom prst="rect">
+            <a:avLst/>
+          </a:prstGeom>
+          <a:noFill/>
+          <a:ln/>
+        </p:spPr>
+        <p:txBody>
+          <a:bodyPr wrap="square" lIns="0" tIns="0" rIns="0" bIns="0" rtlCol="0" anchor="ctr"/>
+          <a:lstStyle/>
+          <a:p>
+            <a:pPr indent="0" marL="0">
+              <a:buNone/>
+            </a:pPr>
+            <a:r>
+              <a:rPr lang="en-US" sz="1600" b="1" dirty="0">
+                <a:solidFill>
+                  <a:srgbClr val="01485C"/>
+                </a:solidFill>
+                <a:latin typeface="Calibri" pitchFamily="34" charset="0"/>
+                <a:ea typeface="Calibri" pitchFamily="34" charset="-122"/>
+                <a:cs typeface="Calibri" pitchFamily="34" charset="-120"/>
+              </a:rPr>
+              <a:t>Site Overview — large sites</a:t>
+            </a:r>
+            <a:endParaRPr lang="en-US" sz="1600" dirty="0"/>
+          </a:p>
+        </p:txBody>
+      </p:sp>
+      <p:sp>
+        <p:nvSpPr>
+          <p:cNvPr id="7" name="Text 5"/>
+          <p:cNvSpPr txBox="1"/>
+          <p:nvPr/>
+        </p:nvSpPr>
+        <p:spPr>
+          <a:xfrm>
+            <a:off x="822960" y="2148840"/>
+            <a:ext cx="4937760" cy="1463040"/>
+          </a:xfrm>
+          <a:prstGeom prst="rect">
+            <a:avLst/>
+          </a:prstGeom>
+          <a:noFill/>
+          <a:ln/>
+        </p:spPr>
+        <p:txBody>
+          <a:bodyPr wrap="square" lIns="0" tIns="0" rIns="0" bIns="0" rtlCol="0" anchor="ctr"/>
+          <a:lstStyle/>
+          <a:p>
+            <a:pPr indent="0" marL="0">
+              <a:buNone/>
+            </a:pPr>
+            <a:r>
+              <a:rPr lang="en-US" sz="1200" dirty="0">
+                <a:solidFill>
+                  <a:srgbClr val="17272E"/>
+                </a:solidFill>
+                <a:latin typeface="Calibri" pitchFamily="34" charset="0"/>
+                <a:ea typeface="Calibri" pitchFamily="34" charset="-122"/>
+                <a:cs typeface="Calibri" pitchFamily="34" charset="-120"/>
+              </a:rPr>
+              <a:t>Every site that is split by ward also gets one page listing each ward’s analyser: cartridges, errors, error % with its band, simulator runs and ceramic ✓/✗, plus a whole-site total. Filed with the ward reports as i-STAT_&lt;Site&gt;_Site_Overview_&lt;Month&gt;.docx</a:t>
+            </a:r>
+            <a:endParaRPr lang="en-US" sz="1300" dirty="0"/>
+          </a:p>
+        </p:txBody>
+      </p:sp>
+      <p:sp>
+        <p:nvSpPr>
+          <p:cNvPr id="8" name="Shape 6"/>
+          <p:cNvSpPr/>
+          <p:nvPr/>
+        </p:nvSpPr>
+        <p:spPr>
+          <a:xfrm>
+            <a:off x="6172200" y="1463040"/>
+            <a:ext cx="5486400" cy="2103120"/>
+          </a:xfrm>
+          <a:prstGeom prst="roundRect">
+            <a:avLst>
+              <a:gd name="adj" fmla="val 5217"/>
+            </a:avLst>
+          </a:prstGeom>
+          <a:solidFill>
+            <a:srgbClr val="FDF0E4"/>
+          </a:solidFill>
+          <a:ln/>
+        </p:spPr>
+        <p:txBody>
+          <a:bodyPr/>
+          <a:p/>
+        </p:txBody>
+      </p:sp>
+      <p:sp>
+        <p:nvSpPr>
+          <p:cNvPr id="9" name="Text 7"/>
+          <p:cNvSpPr txBox="1"/>
+          <p:nvPr/>
+        </p:nvSpPr>
+        <p:spPr>
+          <a:xfrm>
+            <a:off x="6446520" y="1664208"/>
+            <a:ext cx="4937760" cy="411480"/>
+          </a:xfrm>
+          <a:prstGeom prst="rect">
+            <a:avLst/>
+          </a:prstGeom>
+          <a:noFill/>
+          <a:ln/>
+        </p:spPr>
+        <p:txBody>
+          <a:bodyPr wrap="square" lIns="0" tIns="0" rIns="0" bIns="0" rtlCol="0" anchor="ctr"/>
+          <a:lstStyle/>
+          <a:p>
+            <a:pPr indent="0" marL="0">
+              <a:buNone/>
+            </a:pPr>
+            <a:r>
+              <a:rPr lang="en-US" sz="1600" b="1" dirty="0">
+                <a:solidFill>
+                  <a:srgbClr val="B4540A"/>
+                </a:solidFill>
+                <a:latin typeface="Calibri" pitchFamily="34" charset="0"/>
+                <a:ea typeface="Calibri" pitchFamily="34" charset="-122"/>
+                <a:cs typeface="Calibri" pitchFamily="34" charset="-120"/>
+              </a:rPr>
+              <a:t>Dormant analysers — the 4-month rule</a:t>
+            </a:r>
+            <a:endParaRPr lang="en-US" sz="1600" dirty="0"/>
+          </a:p>
+        </p:txBody>
+      </p:sp>
+      <p:sp>
+        <p:nvSpPr>
+          <p:cNvPr id="10" name="Text 8"/>
+          <p:cNvSpPr txBox="1"/>
+          <p:nvPr/>
+        </p:nvSpPr>
+        <p:spPr>
+          <a:xfrm>
+            <a:off x="6446520" y="2148840"/>
+            <a:ext cx="4937760" cy="1463040"/>
+          </a:xfrm>
+          <a:prstGeom prst="rect">
+            <a:avLst/>
+          </a:prstGeom>
+          <a:noFill/>
+          <a:ln/>
+        </p:spPr>
+        <p:txBody>
+          <a:bodyPr wrap="square" lIns="0" tIns="0" rIns="0" bIns="0" rtlCol="0" anchor="ctr"/>
+          <a:lstStyle/>
+          <a:p>
+            <a:pPr indent="0" marL="0">
+              <a:buNone/>
+            </a:pPr>
+            <a:r>
+              <a:rPr lang="en-US" sz="1200" dirty="0">
+                <a:solidFill>
+                  <a:srgbClr val="17272E"/>
+                </a:solidFill>
+                <a:latin typeface="Calibri" pitchFamily="34" charset="0"/>
+                <a:ea typeface="Calibri" pitchFamily="34" charset="-122"/>
+                <a:cs typeface="Calibri" pitchFamily="34" charset="-120"/>
+              </a:rPr>
+              <a:t>An analyser with no cartridges, no simulator runs and no ceramics for 4 consecutive months gets no report and no longer counts against its site’s simulator or ceramic checks. One or two quiet months change nothing. Any use brings it straight back the next month.</a:t>
+            </a:r>
+            <a:endParaRPr lang="en-US" sz="1300" dirty="0"/>
+          </a:p>
+        </p:txBody>
+      </p:sp>
+      <p:sp>
+        <p:nvSpPr>
+          <p:cNvPr id="11" name="Shape 9"/>
+          <p:cNvSpPr/>
+          <p:nvPr/>
+        </p:nvSpPr>
+        <p:spPr>
+          <a:xfrm>
+            <a:off x="548640" y="3749040"/>
+            <a:ext cx="5486400" cy="2103120"/>
+          </a:xfrm>
+          <a:prstGeom prst="roundRect">
+            <a:avLst>
+              <a:gd name="adj" fmla="val 5217"/>
+            </a:avLst>
+          </a:prstGeom>
+          <a:solidFill>
+            <a:srgbClr val="E5F2F0"/>
+          </a:solidFill>
+          <a:ln/>
+        </p:spPr>
+        <p:txBody>
+          <a:bodyPr/>
+          <a:p/>
+        </p:txBody>
+      </p:sp>
+      <p:sp>
+        <p:nvSpPr>
+          <p:cNvPr id="12" name="Text 10"/>
+          <p:cNvSpPr txBox="1"/>
+          <p:nvPr/>
+        </p:nvSpPr>
+        <p:spPr>
+          <a:xfrm>
+            <a:off x="822960" y="3950208"/>
+            <a:ext cx="4937760" cy="411480"/>
+          </a:xfrm>
+          <a:prstGeom prst="rect">
+            <a:avLst/>
+          </a:prstGeom>
+          <a:noFill/>
+          <a:ln/>
+        </p:spPr>
+        <p:txBody>
+          <a:bodyPr wrap="square" lIns="0" tIns="0" rIns="0" bIns="0" rtlCol="0" anchor="ctr"/>
+          <a:lstStyle/>
+          <a:p>
+            <a:pPr indent="0" marL="0">
+              <a:buNone/>
+            </a:pPr>
+            <a:r>
+              <a:rPr lang="en-US" sz="1600" b="1" dirty="0">
+                <a:solidFill>
+                  <a:srgbClr val="01485C"/>
+                </a:solidFill>
+                <a:latin typeface="Calibri" pitchFamily="34" charset="0"/>
+                <a:ea typeface="Calibri" pitchFamily="34" charset="-122"/>
+                <a:cs typeface="Calibri" pitchFamily="34" charset="-120"/>
+              </a:rPr>
+              <a:t>Area Summary — every HHS</a:t>
+            </a:r>
+            <a:endParaRPr lang="en-US" sz="1600" dirty="0"/>
+          </a:p>
+        </p:txBody>
+      </p:sp>
+      <p:sp>
+        <p:nvSpPr>
+          <p:cNvPr id="13" name="Text 11"/>
+          <p:cNvSpPr txBox="1"/>
+          <p:nvPr/>
+        </p:nvSpPr>
+        <p:spPr>
+          <a:xfrm>
+            <a:off x="822960" y="4434840"/>
+            <a:ext cx="4937760" cy="1463040"/>
+          </a:xfrm>
+          <a:prstGeom prst="rect">
+            <a:avLst/>
+          </a:prstGeom>
+          <a:noFill/>
+          <a:ln/>
+        </p:spPr>
+        <p:txBody>
+          <a:bodyPr wrap="square" lIns="0" tIns="0" rIns="0" bIns="0" rtlCol="0" anchor="ctr"/>
+          <a:lstStyle/>
+          <a:p>
+            <a:pPr indent="0" marL="0">
+              <a:buNone/>
+            </a:pPr>
+            <a:r>
+              <a:rPr lang="en-US" sz="1200" dirty="0">
+                <a:solidFill>
+                  <a:srgbClr val="17272E"/>
+                </a:solidFill>
+                <a:latin typeface="Calibri" pitchFamily="34" charset="0"/>
+                <a:ea typeface="Calibri" pitchFamily="34" charset="-122"/>
+                <a:cs typeface="Calibri" pitchFamily="34" charset="-120"/>
+              </a:rPr>
+              <a:t>One per HHS folder each run: every hospital in the area on one page with the same figures, an area total, and an “Analysers Needing Attention” table naming each analyser that ran no simulator or fewer than 3 ceramics. i-STAT_&lt;HHS&gt;_Area_Summary_&lt;Month&gt;.docx</a:t>
+            </a:r>
+            <a:endParaRPr lang="en-US" sz="1300" dirty="0"/>
+          </a:p>
+        </p:txBody>
+      </p:sp>
+      <p:sp>
+        <p:nvSpPr>
+          <p:cNvPr id="14" name="Shape 12"/>
+          <p:cNvSpPr/>
+          <p:nvPr/>
+        </p:nvSpPr>
+        <p:spPr>
+          <a:xfrm>
+            <a:off x="6172200" y="3749040"/>
+            <a:ext cx="5486400" cy="2103120"/>
+          </a:xfrm>
+          <a:prstGeom prst="roundRect">
+            <a:avLst>
+              <a:gd name="adj" fmla="val 5217"/>
+            </a:avLst>
+          </a:prstGeom>
+          <a:solidFill>
+            <a:srgbClr val="E5F2F0"/>
+          </a:solidFill>
+          <a:ln/>
+        </p:spPr>
+        <p:txBody>
+          <a:bodyPr/>
+          <a:p/>
+        </p:txBody>
+      </p:sp>
+      <p:sp>
+        <p:nvSpPr>
+          <p:cNvPr id="15" name="Text 13"/>
+          <p:cNvSpPr txBox="1"/>
+          <p:nvPr/>
+        </p:nvSpPr>
+        <p:spPr>
+          <a:xfrm>
+            <a:off x="6446520" y="3950208"/>
+            <a:ext cx="4937760" cy="411480"/>
+          </a:xfrm>
+          <a:prstGeom prst="rect">
+            <a:avLst/>
+          </a:prstGeom>
+          <a:noFill/>
+          <a:ln/>
+        </p:spPr>
+        <p:txBody>
+          <a:bodyPr wrap="square" lIns="0" tIns="0" rIns="0" bIns="0" rtlCol="0" anchor="ctr"/>
+          <a:lstStyle/>
+          <a:p>
+            <a:pPr indent="0" marL="0">
+              <a:buNone/>
+            </a:pPr>
+            <a:r>
+              <a:rPr lang="en-US" sz="1600" b="1" dirty="0">
+                <a:solidFill>
+                  <a:srgbClr val="01485C"/>
+                </a:solidFill>
+                <a:latin typeface="Calibri" pitchFamily="34" charset="0"/>
+                <a:ea typeface="Calibri" pitchFamily="34" charset="-122"/>
+                <a:cs typeface="Calibri" pitchFamily="34" charset="-120"/>
+              </a:rPr>
+              <a:t>The dormant list</a:t>
+            </a:r>
+            <a:endParaRPr lang="en-US" sz="1600" dirty="0"/>
+          </a:p>
+        </p:txBody>
+      </p:sp>
+      <p:sp>
+        <p:nvSpPr>
+          <p:cNvPr id="16" name="Text 14"/>
+          <p:cNvSpPr txBox="1"/>
+          <p:nvPr/>
+        </p:nvSpPr>
+        <p:spPr>
+          <a:xfrm>
+            <a:off x="6446520" y="4434840"/>
+            <a:ext cx="4937760" cy="1463040"/>
+          </a:xfrm>
+          <a:prstGeom prst="rect">
+            <a:avLst/>
+          </a:prstGeom>
+          <a:noFill/>
+          <a:ln/>
+        </p:spPr>
+        <p:txBody>
+          <a:bodyPr wrap="square" lIns="0" tIns="0" rIns="0" bIns="0" rtlCol="0" anchor="ctr"/>
+          <a:lstStyle/>
+          <a:p>
+            <a:pPr indent="0" marL="0">
+              <a:buNone/>
+            </a:pPr>
+            <a:r>
+              <a:rPr lang="en-US" sz="1200" dirty="0">
+                <a:solidFill>
+                  <a:srgbClr val="17272E"/>
+                </a:solidFill>
+                <a:latin typeface="Calibri" pitchFamily="34" charset="0"/>
+                <a:ea typeface="Calibri" pitchFamily="34" charset="-122"/>
+                <a:cs typeface="Calibri" pitchFamily="34" charset="-120"/>
+              </a:rPr>
+              <a:t>Dormant_iSTATs_&lt;Month&gt;.docx in the reports folder lists every unit left out: hospital, location, serial, months idle and last activity. Check it each month for units to retire — or units that should be in use but are not being maintained. The results card shows the count.</a:t>
+            </a:r>
+            <a:endParaRPr lang="en-US" sz="1300" dirty="0"/>
+          </a:p>
+        </p:txBody>
+      </p:sp>
+      <p:sp>
+        <p:nvSpPr>
+          <p:cNvPr id="17" name="Shape 15"/>
+          <p:cNvSpPr/>
+          <p:nvPr/>
+        </p:nvSpPr>
+        <p:spPr>
+          <a:xfrm>
+            <a:off x="0" y="6793992"/>
+            <a:ext cx="2040636" cy="64008"/>
+          </a:xfrm>
+          <a:prstGeom prst="rect">
+            <a:avLst/>
+          </a:prstGeom>
+          <a:solidFill>
+            <a:srgbClr val="01485C"/>
+          </a:solidFill>
+          <a:ln/>
+        </p:spPr>
+      </p:sp>
+      <p:sp>
+        <p:nvSpPr>
+          <p:cNvPr id="18" name="Shape 16"/>
+          <p:cNvSpPr/>
+          <p:nvPr/>
+        </p:nvSpPr>
+        <p:spPr>
+          <a:xfrm>
+            <a:off x="2031492" y="6793992"/>
+            <a:ext cx="2040636" cy="64008"/>
+          </a:xfrm>
+          <a:prstGeom prst="rect">
+            <a:avLst/>
+          </a:prstGeom>
+          <a:solidFill>
+            <a:srgbClr val="146175"/>
+          </a:solidFill>
+          <a:ln/>
+        </p:spPr>
+      </p:sp>
+      <p:sp>
+        <p:nvSpPr>
+          <p:cNvPr id="19" name="Shape 17"/>
+          <p:cNvSpPr/>
+          <p:nvPr/>
+        </p:nvSpPr>
+        <p:spPr>
+          <a:xfrm>
+            <a:off x="4062984" y="6793992"/>
+            <a:ext cx="2040636" cy="64008"/>
+          </a:xfrm>
+          <a:prstGeom prst="rect">
+            <a:avLst/>
+          </a:prstGeom>
+          <a:solidFill>
+            <a:srgbClr val="11B5AE"/>
+          </a:solidFill>
+          <a:ln/>
+        </p:spPr>
+      </p:sp>
+      <p:sp>
+        <p:nvSpPr>
+          <p:cNvPr id="20" name="Shape 18"/>
+          <p:cNvSpPr/>
+          <p:nvPr/>
+        </p:nvSpPr>
+        <p:spPr>
+          <a:xfrm>
+            <a:off x="6094476" y="6793992"/>
+            <a:ext cx="2040636" cy="64008"/>
+          </a:xfrm>
+          <a:prstGeom prst="rect">
+            <a:avLst/>
+          </a:prstGeom>
+          <a:solidFill>
+            <a:srgbClr val="6CCAD4"/>
+          </a:solidFill>
+          <a:ln/>
+        </p:spPr>
+      </p:sp>
+      <p:sp>
+        <p:nvSpPr>
+          <p:cNvPr id="21" name="Shape 19"/>
+          <p:cNvSpPr/>
+          <p:nvPr/>
+        </p:nvSpPr>
+        <p:spPr>
+          <a:xfrm>
+            <a:off x="8125968" y="6793992"/>
+            <a:ext cx="2040636" cy="64008"/>
+          </a:xfrm>
+          <a:prstGeom prst="rect">
+            <a:avLst/>
+          </a:prstGeom>
+          <a:solidFill>
+            <a:srgbClr val="7FC04C"/>
+          </a:solidFill>
+          <a:ln/>
+        </p:spPr>
+      </p:sp>
+      <p:sp>
+        <p:nvSpPr>
+          <p:cNvPr id="22" name="Shape 20"/>
+          <p:cNvSpPr/>
+          <p:nvPr/>
+        </p:nvSpPr>
+        <p:spPr>
+          <a:xfrm>
+            <a:off x="10157460" y="6793992"/>
+            <a:ext cx="2040636" cy="64008"/>
+          </a:xfrm>
+          <a:prstGeom prst="rect">
+            <a:avLst/>
+          </a:prstGeom>
+          <a:solidFill>
+            <a:srgbClr val="E1DD57"/>
+          </a:solidFill>
+          <a:ln/>
+        </p:spPr>
+      </p:sp>
+    </p:spTree>
+  </p:cSld>
+  <p:clrMapOvr>
+    <a:masterClrMapping/>
+  </p:clrMapOvr>
+</p:sld>
+</file>
+
 <file path=ppt/slides/slide2.xml><?xml version="1.0" encoding="utf-8"?>
 <p:sld xmlns:a="http://schemas.openxmlformats.org/drawingml/2006/main" xmlns:r="http://schemas.openxmlformats.org/officeDocument/2006/relationships" xmlns:p="http://schemas.openxmlformats.org/presentationml/2006/main">
   <p:cSld name="Slide 2">
@@ -14835,6 +15538,10 @@
           </a:solidFill>
           <a:ln/>
         </p:spPr>
+        <p:txBody>
+          <a:bodyPr/>
+          <a:p/>
+        </p:txBody>
       </p:sp>
       <p:sp>
         <p:nvSpPr>
@@ -14894,6 +15601,10 @@
           </a:solidFill>
           <a:ln/>
         </p:spPr>
+        <p:txBody>
+          <a:bodyPr/>
+          <a:p/>
+        </p:txBody>
       </p:sp>
       <p:sp>
         <p:nvSpPr>
@@ -15007,6 +15718,10 @@
           </a:solidFill>
           <a:ln/>
         </p:spPr>
+        <p:txBody>
+          <a:bodyPr/>
+          <a:p/>
+        </p:txBody>
       </p:sp>
       <p:sp>
         <p:nvSpPr>
@@ -15095,7 +15810,7 @@
                 <a:ea typeface="Calibri" pitchFamily="34" charset="-122"/>
                 <a:cs typeface="Calibri" pitchFamily="34" charset="-120"/>
               </a:rPr>
-              <a:t>A progress bar shows each hospital as it is processed.</a:t>
+              <a:t>A progress bar shows each hospital as it is processed and the number of reports written so far.</a:t>
             </a:r>
             <a:endParaRPr lang="en-US" sz="1450" dirty="0"/>
           </a:p>
@@ -15120,6 +15835,10 @@
           </a:solidFill>
           <a:ln/>
         </p:spPr>
+        <p:txBody>
+          <a:bodyPr/>
+          <a:p/>
+        </p:txBody>
       </p:sp>
       <p:sp>
         <p:nvSpPr>
@@ -15208,7 +15927,7 @@
                 <a:ea typeface="Calibri" pitchFamily="34" charset="-122"/>
                 <a:cs typeface="Calibri" pitchFamily="34" charset="-120"/>
               </a:rPr>
-              <a:t>When "Reports Ready" appears, click the button — reports are filed by HHS.</a:t>
+              <a:t>When "Reports Ready" appears, click the button — reports are filed by HHS, with the count of documents written and of dormant analysers left out.</a:t>
             </a:r>
             <a:endParaRPr lang="en-US" sz="1450" dirty="0"/>
           </a:p>
@@ -15235,6 +15954,10 @@
           </a:solidFill>
           <a:ln/>
         </p:spPr>
+        <p:txBody>
+          <a:bodyPr/>
+          <a:p/>
+        </p:txBody>
       </p:sp>
       <p:sp>
         <p:nvSpPr>
@@ -15311,6 +16034,10 @@
           </a:solidFill>
           <a:ln/>
         </p:spPr>
+        <p:txBody>
+          <a:bodyPr/>
+          <a:p/>
+        </p:txBody>
       </p:sp>
       <p:sp>
         <p:nvSpPr>
@@ -15360,7 +16087,7 @@
                 <a:ea typeface="Calibri" pitchFamily="34" charset="-122"/>
                 <a:cs typeface="Calibri" pitchFamily="34" charset="-120"/>
               </a:rPr>
-              <a:t>Townsville, Mt Isa, Mackay and Redcliffe generate one report per device automatically</a:t>
+              <a:t>23 sites, from Townsville to RBWH, get one report per ward plus a Site Overview page</a:t>
             </a:r>
             <a:endParaRPr lang="en-US" sz="1250" dirty="0"/>
           </a:p>

</xml_diff>